<commit_message>
Regenerate AJBA package with all BioEssays figures
Co-Authored-By: Tatsuki Onishi <bougtoir@gmail.com>
</commit_message>
<xml_diff>
--- a/denisovan-archaic-dna-analysis/docs/ajba_submission/figures_tables_ajba.pptx
+++ b/denisovan-archaic-dna-analysis/docs/ajba_submission/figures_tables_ajba.pptx
@@ -16,6 +16,8 @@
     <p:sldId id="264" r:id="rId15"/>
     <p:sldId id="265" r:id="rId16"/>
     <p:sldId id="266" r:id="rId17"/>
+    <p:sldId id="267" r:id="rId18"/>
+    <p:sldId id="268" r:id="rId19"/>
   </p:sldIdLst>
   <p:sldSz cx="12191695" cy="6858000" type="screen4x3"/>
   <p:notesSz cx="6858000" cy="9144000"/>
@@ -3234,6 +3236,222 @@
               </a:defRPr>
             </a:pPr>
             <a:r>
+              <a:t>Figure S1</a:t>
+            </a:r>
+          </a:p>
+        </p:txBody>
+      </p:sp>
+      <p:pic>
+        <p:nvPicPr>
+          <p:cNvPr id="3" name="Picture 2" descr="figS1_full_heatmap.png"/>
+          <p:cNvPicPr>
+            <a:picLocks noChangeAspect="1"/>
+          </p:cNvPicPr>
+          <p:nvPr/>
+        </p:nvPicPr>
+        <p:blipFill>
+          <a:blip r:embed="rId2"/>
+          <a:stretch>
+            <a:fillRect/>
+          </a:stretch>
+        </p:blipFill>
+        <p:spPr>
+          <a:xfrm>
+            <a:off x="1026816" y="777240"/>
+            <a:ext cx="10107887" cy="5166360"/>
+          </a:xfrm>
+          <a:prstGeom prst="rect">
+            <a:avLst/>
+          </a:prstGeom>
+        </p:spPr>
+      </p:pic>
+      <p:sp>
+        <p:nvSpPr>
+          <p:cNvPr id="4" name="TextBox 3"/>
+          <p:cNvSpPr txBox="1"/>
+          <p:nvPr/>
+        </p:nvSpPr>
+        <p:spPr>
+          <a:xfrm>
+            <a:off x="594360" y="5989320"/>
+            <a:ext cx="10972800" cy="658368"/>
+          </a:xfrm>
+          <a:prstGeom prst="rect">
+            <a:avLst/>
+          </a:prstGeom>
+          <a:noFill/>
+        </p:spPr>
+        <p:txBody>
+          <a:bodyPr wrap="square">
+            <a:spAutoFit/>
+          </a:bodyPr>
+          <a:lstStyle/>
+          <a:p>
+            <a:pPr algn="l">
+              <a:defRPr sz="800">
+                <a:latin typeface="Arial"/>
+              </a:defRPr>
+            </a:pPr>
+            <a:r>
+              <a:t>Complete 66-population Neanderthal and Denisovan profile-similarity matrices.</a:t>
+            </a:r>
+          </a:p>
+        </p:txBody>
+      </p:sp>
+    </p:spTree>
+  </p:cSld>
+  <p:clrMapOvr>
+    <a:masterClrMapping/>
+  </p:clrMapOvr>
+</p:sld>
+</file>
+
+<file path=ppt/slides/slide11.xml><?xml version="1.0" encoding="utf-8"?>
+<p:sld xmlns:a="http://schemas.openxmlformats.org/drawingml/2006/main" xmlns:p="http://schemas.openxmlformats.org/presentationml/2006/main" xmlns:r="http://schemas.openxmlformats.org/officeDocument/2006/relationships">
+  <p:cSld>
+    <p:spTree>
+      <p:nvGrpSpPr>
+        <p:cNvPr id="1" name=""/>
+        <p:cNvGrpSpPr/>
+        <p:nvPr/>
+      </p:nvGrpSpPr>
+      <p:grpSpPr/>
+      <p:sp>
+        <p:nvSpPr>
+          <p:cNvPr id="2" name="TextBox 1"/>
+          <p:cNvSpPr txBox="1"/>
+          <p:nvPr/>
+        </p:nvSpPr>
+        <p:spPr>
+          <a:xfrm>
+            <a:off x="548640" y="109728"/>
+            <a:ext cx="11064240" cy="640080"/>
+          </a:xfrm>
+          <a:prstGeom prst="rect">
+            <a:avLst/>
+          </a:prstGeom>
+          <a:noFill/>
+        </p:spPr>
+        <p:txBody>
+          <a:bodyPr wrap="square">
+            <a:spAutoFit/>
+          </a:bodyPr>
+          <a:lstStyle/>
+          <a:p>
+            <a:pPr algn="ctr">
+              <a:defRPr sz="1600" b="1">
+                <a:latin typeface="Arial"/>
+              </a:defRPr>
+            </a:pPr>
+            <a:r>
+              <a:t>Figure S2</a:t>
+            </a:r>
+          </a:p>
+        </p:txBody>
+      </p:sp>
+      <p:pic>
+        <p:nvPicPr>
+          <p:cNvPr id="3" name="Picture 2" descr="figS2_window_sensitivity.png"/>
+          <p:cNvPicPr>
+            <a:picLocks noChangeAspect="1"/>
+          </p:cNvPicPr>
+          <p:nvPr/>
+        </p:nvPicPr>
+        <p:blipFill>
+          <a:blip r:embed="rId2"/>
+          <a:stretch>
+            <a:fillRect/>
+          </a:stretch>
+        </p:blipFill>
+        <p:spPr>
+          <a:xfrm>
+            <a:off x="2032856" y="777240"/>
+            <a:ext cx="8095806" cy="5166360"/>
+          </a:xfrm>
+          <a:prstGeom prst="rect">
+            <a:avLst/>
+          </a:prstGeom>
+        </p:spPr>
+      </p:pic>
+      <p:sp>
+        <p:nvSpPr>
+          <p:cNvPr id="4" name="TextBox 3"/>
+          <p:cNvSpPr txBox="1"/>
+          <p:nvPr/>
+        </p:nvSpPr>
+        <p:spPr>
+          <a:xfrm>
+            <a:off x="594360" y="5989320"/>
+            <a:ext cx="10972800" cy="658368"/>
+          </a:xfrm>
+          <a:prstGeom prst="rect">
+            <a:avLst/>
+          </a:prstGeom>
+          <a:noFill/>
+        </p:spPr>
+        <p:txBody>
+          <a:bodyPr wrap="square">
+            <a:spAutoFit/>
+          </a:bodyPr>
+          <a:lstStyle/>
+          <a:p>
+            <a:pPr algn="l">
+              <a:defRPr sz="800">
+                <a:latin typeface="Arial"/>
+              </a:defRPr>
+            </a:pPr>
+            <a:r>
+              <a:t>Descriptive geographic distance correlations at 250-kb, 500-kb, and 1-Mb window sizes; QAP results are tabulated in Supplementary Data.</a:t>
+            </a:r>
+          </a:p>
+        </p:txBody>
+      </p:sp>
+    </p:spTree>
+  </p:cSld>
+  <p:clrMapOvr>
+    <a:masterClrMapping/>
+  </p:clrMapOvr>
+</p:sld>
+</file>
+
+<file path=ppt/slides/slide12.xml><?xml version="1.0" encoding="utf-8"?>
+<p:sld xmlns:a="http://schemas.openxmlformats.org/drawingml/2006/main" xmlns:p="http://schemas.openxmlformats.org/presentationml/2006/main" xmlns:r="http://schemas.openxmlformats.org/officeDocument/2006/relationships">
+  <p:cSld>
+    <p:spTree>
+      <p:nvGrpSpPr>
+        <p:cNvPr id="1" name=""/>
+        <p:cNvGrpSpPr/>
+        <p:nvPr/>
+      </p:nvGrpSpPr>
+      <p:grpSpPr/>
+      <p:sp>
+        <p:nvSpPr>
+          <p:cNvPr id="2" name="TextBox 1"/>
+          <p:cNvSpPr txBox="1"/>
+          <p:nvPr/>
+        </p:nvSpPr>
+        <p:spPr>
+          <a:xfrm>
+            <a:off x="548640" y="109728"/>
+            <a:ext cx="11064240" cy="640080"/>
+          </a:xfrm>
+          <a:prstGeom prst="rect">
+            <a:avLst/>
+          </a:prstGeom>
+          <a:noFill/>
+        </p:spPr>
+        <p:txBody>
+          <a:bodyPr wrap="square">
+            <a:spAutoFit/>
+          </a:bodyPr>
+          <a:lstStyle/>
+          <a:p>
+            <a:pPr algn="ctr">
+              <a:defRPr sz="1600" b="1">
+                <a:latin typeface="Arial"/>
+              </a:defRPr>
+            </a:pPr>
+            <a:r>
               <a:t>Table 1. Dependence-aware geographic-distance results</a:t>
             </a:r>
           </a:p>
@@ -4168,7 +4386,7 @@
 </p:sld>
 </file>
 
-<file path=ppt/slides/slide11.xml><?xml version="1.0" encoding="utf-8"?>
+<file path=ppt/slides/slide13.xml><?xml version="1.0" encoding="utf-8"?>
 <p:sld xmlns:a="http://schemas.openxmlformats.org/drawingml/2006/main" xmlns:p="http://schemas.openxmlformats.org/presentationml/2006/main" xmlns:r="http://schemas.openxmlformats.org/officeDocument/2006/relationships">
   <p:cSld>
     <p:spTree>
@@ -5628,6 +5846,114 @@
       </p:sp>
       <p:pic>
         <p:nvPicPr>
+          <p:cNvPr id="3" name="Picture 2" descr="fig3_minard_migration.png"/>
+          <p:cNvPicPr>
+            <a:picLocks noChangeAspect="1"/>
+          </p:cNvPicPr>
+          <p:nvPr/>
+        </p:nvPicPr>
+        <p:blipFill>
+          <a:blip r:embed="rId2"/>
+          <a:stretch>
+            <a:fillRect/>
+          </a:stretch>
+        </p:blipFill>
+        <p:spPr>
+          <a:xfrm>
+            <a:off x="1094917" y="777240"/>
+            <a:ext cx="9971685" cy="5166360"/>
+          </a:xfrm>
+          <a:prstGeom prst="rect">
+            <a:avLst/>
+          </a:prstGeom>
+        </p:spPr>
+      </p:pic>
+      <p:sp>
+        <p:nvSpPr>
+          <p:cNvPr id="4" name="TextBox 3"/>
+          <p:cNvSpPr txBox="1"/>
+          <p:nvPr/>
+        </p:nvSpPr>
+        <p:spPr>
+          <a:xfrm>
+            <a:off x="594360" y="5989320"/>
+            <a:ext cx="10972800" cy="658368"/>
+          </a:xfrm>
+          <a:prstGeom prst="rect">
+            <a:avLst/>
+          </a:prstGeom>
+          <a:noFill/>
+        </p:spPr>
+        <p:txBody>
+          <a:bodyPr wrap="square">
+            <a:spAutoFit/>
+          </a:bodyPr>
+          <a:lstStyle/>
+          <a:p>
+            <a:pPr algn="l">
+              <a:defRPr sz="800">
+                <a:latin typeface="Arial"/>
+              </a:defRPr>
+            </a:pPr>
+            <a:r>
+              <a:t>Polygon-based Minard-style schematic of human dispersal and archaic introgression. Band widths, branch positions, and event placement are illustrative and do not estimate migration magnitude, ancestry proportion, or a route supported by the present analysis.</a:t>
+            </a:r>
+          </a:p>
+        </p:txBody>
+      </p:sp>
+    </p:spTree>
+  </p:cSld>
+  <p:clrMapOvr>
+    <a:masterClrMapping/>
+  </p:clrMapOvr>
+</p:sld>
+</file>
+
+<file path=ppt/slides/slide4.xml><?xml version="1.0" encoding="utf-8"?>
+<p:sld xmlns:a="http://schemas.openxmlformats.org/drawingml/2006/main" xmlns:p="http://schemas.openxmlformats.org/presentationml/2006/main" xmlns:r="http://schemas.openxmlformats.org/officeDocument/2006/relationships">
+  <p:cSld>
+    <p:spTree>
+      <p:nvGrpSpPr>
+        <p:cNvPr id="1" name=""/>
+        <p:cNvGrpSpPr/>
+        <p:nvPr/>
+      </p:nvGrpSpPr>
+      <p:grpSpPr/>
+      <p:sp>
+        <p:nvSpPr>
+          <p:cNvPr id="2" name="TextBox 1"/>
+          <p:cNvSpPr txBox="1"/>
+          <p:nvPr/>
+        </p:nvSpPr>
+        <p:spPr>
+          <a:xfrm>
+            <a:off x="548640" y="109728"/>
+            <a:ext cx="11064240" cy="640080"/>
+          </a:xfrm>
+          <a:prstGeom prst="rect">
+            <a:avLst/>
+          </a:prstGeom>
+          <a:noFill/>
+        </p:spPr>
+        <p:txBody>
+          <a:bodyPr wrap="square">
+            <a:spAutoFit/>
+          </a:bodyPr>
+          <a:lstStyle/>
+          <a:p>
+            <a:pPr algn="ctr">
+              <a:defRPr sz="1600" b="1">
+                <a:latin typeface="Arial"/>
+              </a:defRPr>
+            </a:pPr>
+            <a:r>
+              <a:t>Figure 4</a:t>
+            </a:r>
+          </a:p>
+        </p:txBody>
+      </p:sp>
+      <p:pic>
+        <p:nvPicPr>
           <p:cNvPr id="3" name="Picture 2" descr="fig4_sensitivity_admixed.png"/>
           <p:cNvPicPr>
             <a:picLocks noChangeAspect="1"/>
@@ -5691,7 +6017,7 @@
 </p:sld>
 </file>
 
-<file path=ppt/slides/slide4.xml><?xml version="1.0" encoding="utf-8"?>
+<file path=ppt/slides/slide5.xml><?xml version="1.0" encoding="utf-8"?>
 <p:sld xmlns:a="http://schemas.openxmlformats.org/drawingml/2006/main" xmlns:p="http://schemas.openxmlformats.org/presentationml/2006/main" xmlns:r="http://schemas.openxmlformats.org/officeDocument/2006/relationships">
   <p:cSld>
     <p:spTree>
@@ -5729,7 +6055,7 @@
               </a:defRPr>
             </a:pPr>
             <a:r>
-              <a:t>Figure 4</a:t>
+              <a:t>Figure 5</a:t>
             </a:r>
           </a:p>
         </p:txBody>
@@ -5799,7 +6125,7 @@
 </p:sld>
 </file>
 
-<file path=ppt/slides/slide5.xml><?xml version="1.0" encoding="utf-8"?>
+<file path=ppt/slides/slide6.xml><?xml version="1.0" encoding="utf-8"?>
 <p:sld xmlns:a="http://schemas.openxmlformats.org/drawingml/2006/main" xmlns:p="http://schemas.openxmlformats.org/presentationml/2006/main" xmlns:r="http://schemas.openxmlformats.org/officeDocument/2006/relationships">
   <p:cSld>
     <p:spTree>
@@ -5837,223 +6163,7 @@
               </a:defRPr>
             </a:pPr>
             <a:r>
-              <a:t>Figure S1</a:t>
-            </a:r>
-          </a:p>
-        </p:txBody>
-      </p:sp>
-      <p:pic>
-        <p:nvPicPr>
-          <p:cNvPr id="3" name="Picture 2" descr="figS1_full_heatmap.png"/>
-          <p:cNvPicPr>
-            <a:picLocks noChangeAspect="1"/>
-          </p:cNvPicPr>
-          <p:nvPr/>
-        </p:nvPicPr>
-        <p:blipFill>
-          <a:blip r:embed="rId2"/>
-          <a:stretch>
-            <a:fillRect/>
-          </a:stretch>
-        </p:blipFill>
-        <p:spPr>
-          <a:xfrm>
-            <a:off x="1026816" y="777240"/>
-            <a:ext cx="10107887" cy="5166360"/>
-          </a:xfrm>
-          <a:prstGeom prst="rect">
-            <a:avLst/>
-          </a:prstGeom>
-        </p:spPr>
-      </p:pic>
-      <p:sp>
-        <p:nvSpPr>
-          <p:cNvPr id="4" name="TextBox 3"/>
-          <p:cNvSpPr txBox="1"/>
-          <p:nvPr/>
-        </p:nvSpPr>
-        <p:spPr>
-          <a:xfrm>
-            <a:off x="594360" y="5989320"/>
-            <a:ext cx="10972800" cy="658368"/>
-          </a:xfrm>
-          <a:prstGeom prst="rect">
-            <a:avLst/>
-          </a:prstGeom>
-          <a:noFill/>
-        </p:spPr>
-        <p:txBody>
-          <a:bodyPr wrap="square">
-            <a:spAutoFit/>
-          </a:bodyPr>
-          <a:lstStyle/>
-          <a:p>
-            <a:pPr algn="l">
-              <a:defRPr sz="800">
-                <a:latin typeface="Arial"/>
-              </a:defRPr>
-            </a:pPr>
-            <a:r>
-              <a:t>Complete 66-population Neanderthal and Denisovan profile-similarity matrices.</a:t>
-            </a:r>
-          </a:p>
-        </p:txBody>
-      </p:sp>
-    </p:spTree>
-  </p:cSld>
-  <p:clrMapOvr>
-    <a:masterClrMapping/>
-  </p:clrMapOvr>
-</p:sld>
-</file>
-
-<file path=ppt/slides/slide6.xml><?xml version="1.0" encoding="utf-8"?>
-<p:sld xmlns:a="http://schemas.openxmlformats.org/drawingml/2006/main" xmlns:p="http://schemas.openxmlformats.org/presentationml/2006/main" xmlns:r="http://schemas.openxmlformats.org/officeDocument/2006/relationships">
-  <p:cSld>
-    <p:spTree>
-      <p:nvGrpSpPr>
-        <p:cNvPr id="1" name=""/>
-        <p:cNvGrpSpPr/>
-        <p:nvPr/>
-      </p:nvGrpSpPr>
-      <p:grpSpPr/>
-      <p:sp>
-        <p:nvSpPr>
-          <p:cNvPr id="2" name="TextBox 1"/>
-          <p:cNvSpPr txBox="1"/>
-          <p:nvPr/>
-        </p:nvSpPr>
-        <p:spPr>
-          <a:xfrm>
-            <a:off x="548640" y="109728"/>
-            <a:ext cx="11064240" cy="640080"/>
-          </a:xfrm>
-          <a:prstGeom prst="rect">
-            <a:avLst/>
-          </a:prstGeom>
-          <a:noFill/>
-        </p:spPr>
-        <p:txBody>
-          <a:bodyPr wrap="square">
-            <a:spAutoFit/>
-          </a:bodyPr>
-          <a:lstStyle/>
-          <a:p>
-            <a:pPr algn="ctr">
-              <a:defRPr sz="1600" b="1">
-                <a:latin typeface="Arial"/>
-              </a:defRPr>
-            </a:pPr>
-            <a:r>
-              <a:t>Figure S2</a:t>
-            </a:r>
-          </a:p>
-        </p:txBody>
-      </p:sp>
-      <p:pic>
-        <p:nvPicPr>
-          <p:cNvPr id="3" name="Picture 2" descr="figS2_window_sensitivity.png"/>
-          <p:cNvPicPr>
-            <a:picLocks noChangeAspect="1"/>
-          </p:cNvPicPr>
-          <p:nvPr/>
-        </p:nvPicPr>
-        <p:blipFill>
-          <a:blip r:embed="rId2"/>
-          <a:stretch>
-            <a:fillRect/>
-          </a:stretch>
-        </p:blipFill>
-        <p:spPr>
-          <a:xfrm>
-            <a:off x="2032856" y="777240"/>
-            <a:ext cx="8095806" cy="5166360"/>
-          </a:xfrm>
-          <a:prstGeom prst="rect">
-            <a:avLst/>
-          </a:prstGeom>
-        </p:spPr>
-      </p:pic>
-      <p:sp>
-        <p:nvSpPr>
-          <p:cNvPr id="4" name="TextBox 3"/>
-          <p:cNvSpPr txBox="1"/>
-          <p:nvPr/>
-        </p:nvSpPr>
-        <p:spPr>
-          <a:xfrm>
-            <a:off x="594360" y="5989320"/>
-            <a:ext cx="10972800" cy="658368"/>
-          </a:xfrm>
-          <a:prstGeom prst="rect">
-            <a:avLst/>
-          </a:prstGeom>
-          <a:noFill/>
-        </p:spPr>
-        <p:txBody>
-          <a:bodyPr wrap="square">
-            <a:spAutoFit/>
-          </a:bodyPr>
-          <a:lstStyle/>
-          <a:p>
-            <a:pPr algn="l">
-              <a:defRPr sz="800">
-                <a:latin typeface="Arial"/>
-              </a:defRPr>
-            </a:pPr>
-            <a:r>
-              <a:t>Descriptive geographic distance correlations at 250-kb, 500-kb, and 1-Mb window sizes; QAP results are tabulated in Supplementary Data.</a:t>
-            </a:r>
-          </a:p>
-        </p:txBody>
-      </p:sp>
-    </p:spTree>
-  </p:cSld>
-  <p:clrMapOvr>
-    <a:masterClrMapping/>
-  </p:clrMapOvr>
-</p:sld>
-</file>
-
-<file path=ppt/slides/slide7.xml><?xml version="1.0" encoding="utf-8"?>
-<p:sld xmlns:a="http://schemas.openxmlformats.org/drawingml/2006/main" xmlns:p="http://schemas.openxmlformats.org/presentationml/2006/main" xmlns:r="http://schemas.openxmlformats.org/officeDocument/2006/relationships">
-  <p:cSld>
-    <p:spTree>
-      <p:nvGrpSpPr>
-        <p:cNvPr id="1" name=""/>
-        <p:cNvGrpSpPr/>
-        <p:nvPr/>
-      </p:nvGrpSpPr>
-      <p:grpSpPr/>
-      <p:sp>
-        <p:nvSpPr>
-          <p:cNvPr id="2" name="TextBox 1"/>
-          <p:cNvSpPr txBox="1"/>
-          <p:nvPr/>
-        </p:nvSpPr>
-        <p:spPr>
-          <a:xfrm>
-            <a:off x="548640" y="109728"/>
-            <a:ext cx="11064240" cy="640080"/>
-          </a:xfrm>
-          <a:prstGeom prst="rect">
-            <a:avLst/>
-          </a:prstGeom>
-          <a:noFill/>
-        </p:spPr>
-        <p:txBody>
-          <a:bodyPr wrap="square">
-            <a:spAutoFit/>
-          </a:bodyPr>
-          <a:lstStyle/>
-          <a:p>
-            <a:pPr algn="ctr">
-              <a:defRPr sz="1600" b="1">
-                <a:latin typeface="Arial"/>
-              </a:defRPr>
-            </a:pPr>
-            <a:r>
-              <a:t>Figure S3</a:t>
+              <a:t>Figure 6</a:t>
             </a:r>
           </a:p>
         </p:txBody>
@@ -6110,7 +6220,7 @@
               </a:defRPr>
             </a:pPr>
             <a:r>
-              <a:t>O2-defining allele frequencies and ABO-window segment-carrier frequencies. The panels use different sources and are not an association analysis.</a:t>
+              <a:t>O2-defining allele frequencies and ABO-window segment-carrier frequencies. The panels use different sources and are not an association analysis; proximity does not establish that the O2 allele is Neanderthal-derived.</a:t>
             </a:r>
           </a:p>
         </p:txBody>
@@ -6123,7 +6233,7 @@
 </p:sld>
 </file>
 
-<file path=ppt/slides/slide8.xml><?xml version="1.0" encoding="utf-8"?>
+<file path=ppt/slides/slide7.xml><?xml version="1.0" encoding="utf-8"?>
 <p:sld xmlns:a="http://schemas.openxmlformats.org/drawingml/2006/main" xmlns:p="http://schemas.openxmlformats.org/presentationml/2006/main" xmlns:r="http://schemas.openxmlformats.org/officeDocument/2006/relationships">
   <p:cSld>
     <p:spTree>
@@ -6161,7 +6271,7 @@
               </a:defRPr>
             </a:pPr>
             <a:r>
-              <a:t>Figure S4</a:t>
+              <a:t>Figure 7</a:t>
             </a:r>
           </a:p>
         </p:txBody>
@@ -6231,7 +6341,7 @@
 </p:sld>
 </file>
 
-<file path=ppt/slides/slide9.xml><?xml version="1.0" encoding="utf-8"?>
+<file path=ppt/slides/slide8.xml><?xml version="1.0" encoding="utf-8"?>
 <p:sld xmlns:a="http://schemas.openxmlformats.org/drawingml/2006/main" xmlns:p="http://schemas.openxmlformats.org/presentationml/2006/main" xmlns:r="http://schemas.openxmlformats.org/officeDocument/2006/relationships">
   <p:cSld>
     <p:spTree>
@@ -6269,7 +6379,7 @@
               </a:defRPr>
             </a:pPr>
             <a:r>
-              <a:t>Figure S5</a:t>
+              <a:t>Figure 8</a:t>
             </a:r>
           </a:p>
         </p:txBody>
@@ -6327,6 +6437,114 @@
             </a:pPr>
             <a:r>
               <a:t>Descriptive ancient and modern ABO-window summaries generated by different pipelines; no formal temporal comparison is made.</a:t>
+            </a:r>
+          </a:p>
+        </p:txBody>
+      </p:sp>
+    </p:spTree>
+  </p:cSld>
+  <p:clrMapOvr>
+    <a:masterClrMapping/>
+  </p:clrMapOvr>
+</p:sld>
+</file>
+
+<file path=ppt/slides/slide9.xml><?xml version="1.0" encoding="utf-8"?>
+<p:sld xmlns:a="http://schemas.openxmlformats.org/drawingml/2006/main" xmlns:p="http://schemas.openxmlformats.org/presentationml/2006/main" xmlns:r="http://schemas.openxmlformats.org/officeDocument/2006/relationships">
+  <p:cSld>
+    <p:spTree>
+      <p:nvGrpSpPr>
+        <p:cNvPr id="1" name=""/>
+        <p:cNvGrpSpPr/>
+        <p:nvPr/>
+      </p:nvGrpSpPr>
+      <p:grpSpPr/>
+      <p:sp>
+        <p:nvSpPr>
+          <p:cNvPr id="2" name="TextBox 1"/>
+          <p:cNvSpPr txBox="1"/>
+          <p:nvPr/>
+        </p:nvSpPr>
+        <p:spPr>
+          <a:xfrm>
+            <a:off x="548640" y="109728"/>
+            <a:ext cx="11064240" cy="640080"/>
+          </a:xfrm>
+          <a:prstGeom prst="rect">
+            <a:avLst/>
+          </a:prstGeom>
+          <a:noFill/>
+        </p:spPr>
+        <p:txBody>
+          <a:bodyPr wrap="square">
+            <a:spAutoFit/>
+          </a:bodyPr>
+          <a:lstStyle/>
+          <a:p>
+            <a:pPr algn="ctr">
+              <a:defRPr sz="1600" b="1">
+                <a:latin typeface="Arial"/>
+              </a:defRPr>
+            </a:pPr>
+            <a:r>
+              <a:t>Figure 9</a:t>
+            </a:r>
+          </a:p>
+        </p:txBody>
+      </p:sp>
+      <p:pic>
+        <p:nvPicPr>
+          <p:cNvPr id="3" name="Picture 2" descr="fig9_bivariate_world_map.png"/>
+          <p:cNvPicPr>
+            <a:picLocks noChangeAspect="1"/>
+          </p:cNvPicPr>
+          <p:nvPr/>
+        </p:nvPicPr>
+        <p:blipFill>
+          <a:blip r:embed="rId2"/>
+          <a:stretch>
+            <a:fillRect/>
+          </a:stretch>
+        </p:blipFill>
+        <p:spPr>
+          <a:xfrm>
+            <a:off x="1815376" y="777239"/>
+            <a:ext cx="8530766" cy="5166360"/>
+          </a:xfrm>
+          <a:prstGeom prst="rect">
+            <a:avLst/>
+          </a:prstGeom>
+        </p:spPr>
+      </p:pic>
+      <p:sp>
+        <p:nvSpPr>
+          <p:cNvPr id="4" name="TextBox 3"/>
+          <p:cNvSpPr txBox="1"/>
+          <p:nvPr/>
+        </p:nvSpPr>
+        <p:spPr>
+          <a:xfrm>
+            <a:off x="594360" y="5989320"/>
+            <a:ext cx="10972800" cy="658368"/>
+          </a:xfrm>
+          <a:prstGeom prst="rect">
+            <a:avLst/>
+          </a:prstGeom>
+          <a:noFill/>
+        </p:spPr>
+        <p:txBody>
+          <a:bodyPr wrap="square">
+            <a:spAutoFit/>
+          </a:bodyPr>
+          <a:lstStyle/>
+          <a:p>
+            <a:pPr algn="l">
+              <a:defRPr sz="800">
+                <a:latin typeface="Arial"/>
+              </a:defRPr>
+            </a:pPr>
+            <a:r>
+              <a:t>Literature-derived global context. Circle size represents approximate Neanderthal ancestry and color intensity represents approximate Denisovan ancestry. Values were not used in the pairwise statistical models.</a:t>
             </a:r>
           </a:p>
         </p:txBody>

</xml_diff>